<commit_message>
Redesign slide 4 bars as a thickness-tapered funnel with amount labels
Replace the barChart object with 9 manually positioned rectangles whose
height (not just length) decreases with each customer's share, producing
a visible funnel/pyramid taper. Each row now shows name, percent and the
NIS-million amount from the user's table; the smallest rows place their
percent+amount label in the open space beside the bar instead of inside
it to avoid text overflow. Slides 1, 2, 3 and 5 are untouched (verified
byte-identical).

Co-Authored-By: Claude Sonnet 5 <noreply@anthropic.com>
Claude-Session: https://claude.ai/code/session_01E9QvuhBZminJvrtKVH8YY8
</commit_message>
<xml_diff>
--- a/svetlana/outputs/2026-10-27-מכירות-סטטוס-ותחזית-2026-V3.pptx
+++ b/svetlana/outputs/2026-10-27-מכירות-סטטוס-ותחזית-2026-V3.pptx
@@ -1833,428 +1833,6 @@
     </a:p>
   </c:txPr>
   <c:externalData r:id="rId3">
-    <c:autoUpdate val="0"/>
-  </c:externalData>
-</c:chartSpace>
-</file>
-
-<file path=ppt/charts/chart4.xml><?xml version="1.0" encoding="utf-8"?>
-<c:chartSpace xmlns:c="http://schemas.openxmlformats.org/drawingml/2006/chart" xmlns:a="http://schemas.openxmlformats.org/drawingml/2006/main" xmlns:r="http://schemas.openxmlformats.org/officeDocument/2006/relationships" xmlns:c16r2="http://schemas.microsoft.com/office/drawing/2015/06/chart">
-  <c:date1904 val="0"/>
-  <c:lang val="he-IL"/>
-  <c:roundedCorners val="0"/>
-  <mc:AlternateContent xmlns:mc="http://schemas.openxmlformats.org/markup-compatibility/2006">
-    <mc:Choice xmlns:c14="http://schemas.microsoft.com/office/drawing/2007/8/2/chart" Requires="c14">
-      <c14:style val="102"/>
-    </mc:Choice>
-    <mc:Fallback>
-      <c:style val="2"/>
-    </mc:Fallback>
-  </mc:AlternateContent>
-  <c:chart>
-    <c:autoTitleDeleted val="1"/>
-    <c:plotArea>
-      <c:layout/>
-      <c:barChart>
-        <c:barDir val="bar"/>
-        <c:grouping val="clustered"/>
-        <c:varyColors val="1"/>
-        <c:ser>
-          <c:idx val="0"/>
-          <c:order val="0"/>
-          <c:spPr>
-            <a:solidFill>
-              <a:srgbClr val="002F6C"/>
-            </a:solidFill>
-            <a:ln>
-              <a:noFill/>
-            </a:ln>
-            <a:effectLst/>
-          </c:spPr>
-          <c:invertIfNegative val="0"/>
-          <c:dPt>
-            <c:idx val="0"/>
-            <c:invertIfNegative val="0"/>
-            <c:bubble3D val="0"/>
-            <c:spPr>
-              <a:solidFill>
-                <a:srgbClr val="E0A62B"/>
-              </a:solidFill>
-              <a:ln>
-                <a:noFill/>
-              </a:ln>
-              <a:effectLst/>
-            </c:spPr>
-            <c:extLst>
-              <c:ext xmlns:c16="http://schemas.microsoft.com/office/drawing/2014/chart" uri="{C3380CC4-5D6E-409C-BE32-E72D297353CC}">
-                <c16:uniqueId val="{00000001-49D1-465C-A359-7B587FFD6284}"/>
-              </c:ext>
-            </c:extLst>
-          </c:dPt>
-          <c:dPt>
-            <c:idx val="1"/>
-            <c:invertIfNegative val="0"/>
-            <c:bubble3D val="0"/>
-            <c:extLst>
-              <c:ext xmlns:c16="http://schemas.microsoft.com/office/drawing/2014/chart" uri="{C3380CC4-5D6E-409C-BE32-E72D297353CC}">
-                <c16:uniqueId val="{00000003-49D1-465C-A359-7B587FFD6284}"/>
-              </c:ext>
-            </c:extLst>
-          </c:dPt>
-          <c:dPt>
-            <c:idx val="2"/>
-            <c:invertIfNegative val="0"/>
-            <c:bubble3D val="0"/>
-            <c:spPr>
-              <a:solidFill>
-                <a:srgbClr val="1D4881"/>
-              </a:solidFill>
-              <a:ln>
-                <a:noFill/>
-              </a:ln>
-              <a:effectLst/>
-            </c:spPr>
-            <c:extLst>
-              <c:ext xmlns:c16="http://schemas.microsoft.com/office/drawing/2014/chart" uri="{C3380CC4-5D6E-409C-BE32-E72D297353CC}">
-                <c16:uniqueId val="{00000005-49D1-465C-A359-7B587FFD6284}"/>
-              </c:ext>
-            </c:extLst>
-          </c:dPt>
-          <c:dPt>
-            <c:idx val="3"/>
-            <c:invertIfNegative val="0"/>
-            <c:bubble3D val="0"/>
-            <c:spPr>
-              <a:solidFill>
-                <a:srgbClr val="3A6095"/>
-              </a:solidFill>
-              <a:ln>
-                <a:noFill/>
-              </a:ln>
-              <a:effectLst/>
-            </c:spPr>
-            <c:extLst>
-              <c:ext xmlns:c16="http://schemas.microsoft.com/office/drawing/2014/chart" uri="{C3380CC4-5D6E-409C-BE32-E72D297353CC}">
-                <c16:uniqueId val="{00000007-49D1-465C-A359-7B587FFD6284}"/>
-              </c:ext>
-            </c:extLst>
-          </c:dPt>
-          <c:dPt>
-            <c:idx val="4"/>
-            <c:invertIfNegative val="0"/>
-            <c:bubble3D val="0"/>
-            <c:spPr>
-              <a:solidFill>
-                <a:srgbClr val="5779AA"/>
-              </a:solidFill>
-              <a:ln>
-                <a:noFill/>
-              </a:ln>
-              <a:effectLst/>
-            </c:spPr>
-            <c:extLst>
-              <c:ext xmlns:c16="http://schemas.microsoft.com/office/drawing/2014/chart" uri="{C3380CC4-5D6E-409C-BE32-E72D297353CC}">
-                <c16:uniqueId val="{00000009-49D1-465C-A359-7B587FFD6284}"/>
-              </c:ext>
-            </c:extLst>
-          </c:dPt>
-          <c:dPt>
-            <c:idx val="5"/>
-            <c:invertIfNegative val="0"/>
-            <c:bubble3D val="0"/>
-            <c:spPr>
-              <a:solidFill>
-                <a:srgbClr val="7392BE"/>
-              </a:solidFill>
-              <a:ln>
-                <a:noFill/>
-              </a:ln>
-              <a:effectLst/>
-            </c:spPr>
-            <c:extLst>
-              <c:ext xmlns:c16="http://schemas.microsoft.com/office/drawing/2014/chart" uri="{C3380CC4-5D6E-409C-BE32-E72D297353CC}">
-                <c16:uniqueId val="{0000000B-49D1-465C-A359-7B587FFD6284}"/>
-              </c:ext>
-            </c:extLst>
-          </c:dPt>
-          <c:dPt>
-            <c:idx val="6"/>
-            <c:invertIfNegative val="0"/>
-            <c:bubble3D val="0"/>
-            <c:spPr>
-              <a:solidFill>
-                <a:srgbClr val="90ABD3"/>
-              </a:solidFill>
-              <a:ln>
-                <a:noFill/>
-              </a:ln>
-              <a:effectLst/>
-            </c:spPr>
-            <c:extLst>
-              <c:ext xmlns:c16="http://schemas.microsoft.com/office/drawing/2014/chart" uri="{C3380CC4-5D6E-409C-BE32-E72D297353CC}">
-                <c16:uniqueId val="{0000000D-49D1-465C-A359-7B587FFD6284}"/>
-              </c:ext>
-            </c:extLst>
-          </c:dPt>
-          <c:dPt>
-            <c:idx val="7"/>
-            <c:invertIfNegative val="0"/>
-            <c:bubble3D val="0"/>
-            <c:spPr>
-              <a:solidFill>
-                <a:srgbClr val="ADC3E7"/>
-              </a:solidFill>
-              <a:ln>
-                <a:noFill/>
-              </a:ln>
-              <a:effectLst/>
-            </c:spPr>
-            <c:extLst>
-              <c:ext xmlns:c16="http://schemas.microsoft.com/office/drawing/2014/chart" uri="{C3380CC4-5D6E-409C-BE32-E72D297353CC}">
-                <c16:uniqueId val="{0000000F-49D1-465C-A359-7B587FFD6284}"/>
-              </c:ext>
-            </c:extLst>
-          </c:dPt>
-          <c:dPt>
-            <c:idx val="8"/>
-            <c:invertIfNegative val="0"/>
-            <c:bubble3D val="0"/>
-            <c:spPr>
-              <a:solidFill>
-                <a:srgbClr val="CADCFC"/>
-              </a:solidFill>
-              <a:ln>
-                <a:noFill/>
-              </a:ln>
-              <a:effectLst/>
-            </c:spPr>
-            <c:extLst>
-              <c:ext xmlns:c16="http://schemas.microsoft.com/office/drawing/2014/chart" uri="{C3380CC4-5D6E-409C-BE32-E72D297353CC}">
-                <c16:uniqueId val="{00000011-49D1-465C-A359-7B587FFD6284}"/>
-              </c:ext>
-            </c:extLst>
-          </c:dPt>
-          <c:dLbls>
-            <c:numFmt formatCode="0%" sourceLinked="0"/>
-            <c:spPr>
-              <a:noFill/>
-              <a:ln>
-                <a:noFill/>
-              </a:ln>
-              <a:effectLst/>
-            </c:spPr>
-            <c:txPr>
-              <a:bodyPr rot="0" spcFirstLastPara="1" vertOverflow="ellipsis" vert="horz" wrap="square" lIns="38100" tIns="19050" rIns="38100" bIns="19050" anchor="ctr" anchorCtr="1">
-                <a:spAutoFit/>
-              </a:bodyPr>
-              <a:lstStyle/>
-              <a:p>
-                <a:pPr>
-                  <a:defRPr sz="1100" b="1" i="0" u="none" strike="noStrike" kern="1200" baseline="0">
-                    <a:solidFill>
-                      <a:srgbClr val="002F6C"/>
-                    </a:solidFill>
-                    <a:latin typeface="+mn-lt"/>
-                    <a:ea typeface="+mn-ea"/>
-                    <a:cs typeface="+mn-cs"/>
-                  </a:defRPr>
-                </a:pPr>
-                <a:endParaRPr lang="he-IL"/>
-              </a:p>
-            </c:txPr>
-            <c:dLblPos val="outEnd"/>
-            <c:showLegendKey val="0"/>
-            <c:showVal val="1"/>
-            <c:showCatName val="0"/>
-            <c:showSerName val="0"/>
-            <c:showPercent val="0"/>
-            <c:showBubbleSize val="0"/>
-            <c:showLeaderLines val="0"/>
-            <c:extLst>
-              <c:ext xmlns:c15="http://schemas.microsoft.com/office/drawing/2012/chart" uri="{CE6537A1-D6FC-4f65-9D91-7224C49458BB}">
-                <c15:showLeaderLines val="0"/>
-              </c:ext>
-            </c:extLst>
-          </c:dLbls>
-          <c:cat>
-            <c:strRef>
-              <c:f>'2026'!$P$50:$P$58</c:f>
-              <c:strCache>
-                <c:ptCount val="9"/>
-                <c:pt idx="0">
-                  <c:v>ס.פארם</c:v>
-                </c:pt>
-                <c:pt idx="1">
-                  <c:v>אתר </c:v>
-                </c:pt>
-                <c:pt idx="2">
-                  <c:v>קופות</c:v>
-                </c:pt>
-                <c:pt idx="3">
-                  <c:v>מפיצים </c:v>
-                </c:pt>
-                <c:pt idx="4">
-                  <c:v>אמזון </c:v>
-                </c:pt>
-                <c:pt idx="5">
-                  <c:v>בתי מרקחת</c:v>
-                </c:pt>
-                <c:pt idx="6">
-                  <c:v>מכונים</c:v>
-                </c:pt>
-                <c:pt idx="7">
-                  <c:v>BE</c:v>
-                </c:pt>
-                <c:pt idx="8">
-                  <c:v>אחרים </c:v>
-                </c:pt>
-              </c:strCache>
-            </c:strRef>
-          </c:cat>
-          <c:val>
-            <c:numRef>
-              <c:f>'2026'!$Q$50:$Q$58</c:f>
-              <c:numCache>
-                <c:formatCode>0%</c:formatCode>
-                <c:ptCount val="9"/>
-                <c:pt idx="0">
-                  <c:v>0.28889797959581626</c:v>
-                </c:pt>
-                <c:pt idx="1">
-                  <c:v>0.19072350419474854</c:v>
-                </c:pt>
-                <c:pt idx="2">
-                  <c:v>0.15791549370270344</c:v>
-                </c:pt>
-                <c:pt idx="3">
-                  <c:v>0.10982113660021957</c:v>
-                </c:pt>
-                <c:pt idx="4">
-                  <c:v>9.7027520387894292E-2</c:v>
-                </c:pt>
-                <c:pt idx="5">
-                  <c:v>7.0896533809474291E-2</c:v>
-                </c:pt>
-                <c:pt idx="6">
-                  <c:v>4.1106631992353412E-2</c:v>
-                </c:pt>
-                <c:pt idx="7">
-                  <c:v>3.5158290842720485E-2</c:v>
-                </c:pt>
-                <c:pt idx="8">
-                  <c:v>8.4529088740696295E-3</c:v>
-                </c:pt>
-              </c:numCache>
-            </c:numRef>
-          </c:val>
-          <c:extLst>
-            <c:ext xmlns:c16="http://schemas.microsoft.com/office/drawing/2014/chart" uri="{C3380CC4-5D6E-409C-BE32-E72D297353CC}">
-              <c16:uniqueId val="{00000001-AAAA-4A2F-A324-30BA285687A9}"/>
-            </c:ext>
-          </c:extLst>
-        </c:ser>
-        <c:dLbls>
-          <c:showLegendKey val="0"/>
-          <c:showVal val="0"/>
-          <c:showCatName val="0"/>
-          <c:showSerName val="0"/>
-          <c:showPercent val="0"/>
-          <c:showBubbleSize val="0"/>
-        </c:dLbls>
-        <c:gapWidth val="45"/>
-        <c:axId val="411000001"/>
-        <c:axId val="411000002"/>
-      </c:barChart>
-      <c:catAx>
-        <c:axId val="411000001"/>
-        <c:scaling>
-          <c:orientation val="maxMin"/>
-        </c:scaling>
-        <c:delete val="0"/>
-        <c:axPos val="r"/>
-        <c:numFmt formatCode="General" sourceLinked="1"/>
-        <c:majorTickMark val="none"/>
-        <c:minorTickMark val="none"/>
-        <c:tickLblPos val="nextTo"/>
-        <c:spPr>
-          <a:noFill/>
-          <a:ln w="9525" cap="flat" cmpd="sng" algn="ctr">
-            <a:noFill/>
-            <a:round/>
-          </a:ln>
-          <a:effectLst/>
-        </c:spPr>
-        <c:txPr>
-          <a:bodyPr rot="0" spcFirstLastPara="1" vertOverflow="ellipsis" vert="horz" wrap="square" anchor="ctr" anchorCtr="1"/>
-          <a:lstStyle/>
-          <a:p>
-            <a:pPr>
-              <a:defRPr sz="1200" b="1" i="0" u="none" strike="noStrike" kern="1200" baseline="0">
-                <a:solidFill>
-                  <a:srgbClr val="002F6C"/>
-                </a:solidFill>
-                <a:latin typeface="+mn-lt"/>
-                <a:ea typeface="+mn-ea"/>
-                <a:cs typeface="+mn-cs"/>
-              </a:defRPr>
-            </a:pPr>
-            <a:endParaRPr lang="he-IL"/>
-          </a:p>
-        </c:txPr>
-        <c:crossAx val="411000002"/>
-        <c:crosses val="autoZero"/>
-        <c:auto val="1"/>
-        <c:lblAlgn val="ctr"/>
-        <c:lblOffset val="100"/>
-        <c:noMultiLvlLbl val="0"/>
-      </c:catAx>
-      <c:valAx>
-        <c:axId val="411000002"/>
-        <c:scaling>
-          <c:orientation val="maxMin"/>
-          <c:max val="0.34"/>
-          <c:min val="0"/>
-        </c:scaling>
-        <c:delete val="1"/>
-        <c:axPos val="t"/>
-        <c:numFmt formatCode="0%" sourceLinked="0"/>
-        <c:majorTickMark val="none"/>
-        <c:minorTickMark val="none"/>
-        <c:tickLblPos val="none"/>
-        <c:crossAx val="411000001"/>
-        <c:crosses val="autoZero"/>
-        <c:crossBetween val="between"/>
-      </c:valAx>
-      <c:spPr>
-        <a:noFill/>
-        <a:ln>
-          <a:noFill/>
-        </a:ln>
-        <a:effectLst/>
-      </c:spPr>
-    </c:plotArea>
-    <c:plotVisOnly val="1"/>
-    <c:dispBlanksAs val="gap"/>
-    <c:showDLblsOverMax val="0"/>
-  </c:chart>
-  <c:spPr>
-    <a:noFill/>
-    <a:ln>
-      <a:noFill/>
-    </a:ln>
-    <a:effectLst/>
-  </c:spPr>
-  <c:txPr>
-    <a:bodyPr/>
-    <a:lstStyle/>
-    <a:p>
-      <a:pPr>
-        <a:defRPr/>
-      </a:pPr>
-      <a:endParaRPr lang="he-IL"/>
-    </a:p>
-  </c:txPr>
-  <c:externalData r:id="rId1">
     <c:autoUpdate val="0"/>
   </c:externalData>
 </c:chartSpace>
@@ -10781,30 +10359,969 @@
           </a:prstGeom>
         </p:spPr>
       </p:pic>
-      <p:graphicFrame>
-        <p:nvGraphicFramePr>
-          <p:cNvPr id="3" name="תרשים 2">
-            <a:extLst>
-              <a:ext uri="{FF2B5EF4-FFF2-40B4-BE49-F238E27FC236}">
-                <a16:creationId xmlns:a16="http://schemas.microsoft.com/office/drawing/2014/main" id="{68DD80F7-0FCE-58D9-C338-40331FEFC556}"/>
-              </a:ext>
-            </a:extLst>
-          </p:cNvPr>
-          <p:cNvGraphicFramePr>
-            <a:graphicFrameLocks/>
-          </p:cNvGraphicFramePr>
+      <p:sp>
+        <p:nvSpPr>
+          <p:cNvPr id="100" name="FunnelBar_ס.פארם"/>
+          <p:cNvSpPr/>
           <p:nvPr/>
-        </p:nvGraphicFramePr>
-        <p:xfrm>
-          <a:off x="1143000" y="1143000"/>
-          <a:ext cx="9906000" cy="4800600"/>
-        </p:xfrm>
-        <a:graphic>
-          <a:graphicData uri="http://schemas.openxmlformats.org/drawingml/2006/chart">
-            <c:chart xmlns:c="http://schemas.openxmlformats.org/drawingml/2006/chart" xmlns:r="http://schemas.openxmlformats.org/officeDocument/2006/relationships" r:id="rId3"/>
-          </a:graphicData>
-        </a:graphic>
-      </p:graphicFrame>
+        </p:nvSpPr>
+        <p:spPr>
+          <a:xfrm>
+            <a:off x="3652800" y="1143000"/>
+            <a:ext cx="5856200" cy="840513"/>
+          </a:xfrm>
+          <a:prstGeom prst="rect">
+            <a:avLst/>
+          </a:prstGeom>
+          <a:solidFill>
+            <a:srgbClr val="E0A62B"/>
+          </a:solidFill>
+          <a:ln>
+            <a:noFill/>
+          </a:ln>
+        </p:spPr>
+        <p:txBody>
+          <a:bodyPr/>
+          <a:lstStyle/>
+          <a:p>
+            <a:endParaRPr lang="he-IL"/>
+          </a:p>
+        </p:txBody>
+      </p:sp>
+      <p:sp>
+        <p:nvSpPr>
+          <p:cNvPr id="101" name="FunnelName_0"/>
+          <p:cNvSpPr txBox="1"/>
+          <p:nvPr/>
+        </p:nvSpPr>
+        <p:spPr>
+          <a:xfrm>
+            <a:off x="9549000" y="1433256"/>
+            <a:ext cx="1500000" cy="260000"/>
+          </a:xfrm>
+          <a:prstGeom prst="rect">
+            <a:avLst/>
+          </a:prstGeom>
+          <a:noFill/>
+          <a:ln>
+            <a:noFill/>
+          </a:ln>
+        </p:spPr>
+        <p:txBody>
+          <a:bodyPr wrap="none" lIns="0" tIns="0" rIns="0" bIns="0" anchor="ctr" anchorCtr="0">
+            <a:noAutofit/>
+          </a:bodyPr>
+          <a:lstStyle/>
+          <a:p>
+            <a:pPr algn="r" rtl="1"/>
+            <a:r>
+              <a:rPr lang="he-IL" sz="1300" b="1" dirty="0">
+                <a:solidFill>
+                  <a:srgbClr val="002F6C"/>
+                </a:solidFill>
+                <a:latin typeface="+mn-lt"/>
+                <a:cs typeface="+mn-lt"/>
+              </a:rPr>
+              <a:t>ס.פארם</a:t>
+            </a:r>
+          </a:p>
+        </p:txBody>
+      </p:sp>
+      <p:sp>
+        <p:nvSpPr>
+          <p:cNvPr id="102" name="FunnelTip_0"/>
+          <p:cNvSpPr txBox="1"/>
+          <p:nvPr/>
+        </p:nvSpPr>
+        <p:spPr>
+          <a:xfrm>
+            <a:off x="1143000" y="1433256"/>
+            <a:ext cx="2449800" cy="260000"/>
+          </a:xfrm>
+          <a:prstGeom prst="rect">
+            <a:avLst/>
+          </a:prstGeom>
+          <a:noFill/>
+          <a:ln>
+            <a:noFill/>
+          </a:ln>
+        </p:spPr>
+        <p:txBody>
+          <a:bodyPr wrap="none" lIns="0" tIns="0" rIns="0" bIns="0" anchor="ctr" anchorCtr="0">
+            <a:noAutofit/>
+          </a:bodyPr>
+          <a:lstStyle/>
+          <a:p>
+            <a:pPr algn="r" rtl="1"/>
+            <a:r>
+              <a:rPr lang="he-IL" sz="1300" b="1" dirty="0">
+                <a:solidFill>
+                  <a:srgbClr val="002F6C"/>
+                </a:solidFill>
+                <a:latin typeface="+mn-lt"/>
+                <a:cs typeface="+mn-lt"/>
+              </a:rPr>
+              <a:t>28.9%   7.9 ₪ מיליון</a:t>
+            </a:r>
+          </a:p>
+        </p:txBody>
+      </p:sp>
+      <p:sp>
+        <p:nvSpPr>
+          <p:cNvPr id="103" name="FunnelBar_אתר"/>
+          <p:cNvSpPr/>
+          <p:nvPr/>
+        </p:nvSpPr>
+        <p:spPr>
+          <a:xfrm>
+            <a:off x="5642868" y="2043513"/>
+            <a:ext cx="3866132" cy="682928"/>
+          </a:xfrm>
+          <a:prstGeom prst="rect">
+            <a:avLst/>
+          </a:prstGeom>
+          <a:solidFill>
+            <a:srgbClr val="002F6C"/>
+          </a:solidFill>
+          <a:ln>
+            <a:noFill/>
+          </a:ln>
+        </p:spPr>
+        <p:txBody>
+          <a:bodyPr/>
+          <a:lstStyle/>
+          <a:p>
+            <a:endParaRPr lang="he-IL"/>
+          </a:p>
+        </p:txBody>
+      </p:sp>
+      <p:sp>
+        <p:nvSpPr>
+          <p:cNvPr id="104" name="FunnelName_1"/>
+          <p:cNvSpPr txBox="1"/>
+          <p:nvPr/>
+        </p:nvSpPr>
+        <p:spPr>
+          <a:xfrm>
+            <a:off x="9549000" y="2254977"/>
+            <a:ext cx="1500000" cy="260000"/>
+          </a:xfrm>
+          <a:prstGeom prst="rect">
+            <a:avLst/>
+          </a:prstGeom>
+          <a:noFill/>
+          <a:ln>
+            <a:noFill/>
+          </a:ln>
+        </p:spPr>
+        <p:txBody>
+          <a:bodyPr wrap="none" lIns="0" tIns="0" rIns="0" bIns="0" anchor="ctr" anchorCtr="0">
+            <a:noAutofit/>
+          </a:bodyPr>
+          <a:lstStyle/>
+          <a:p>
+            <a:pPr algn="r" rtl="1"/>
+            <a:r>
+              <a:rPr lang="he-IL" sz="1300" b="1" dirty="0">
+                <a:solidFill>
+                  <a:srgbClr val="002F6C"/>
+                </a:solidFill>
+                <a:latin typeface="+mn-lt"/>
+                <a:cs typeface="+mn-lt"/>
+              </a:rPr>
+              <a:t>אתר</a:t>
+            </a:r>
+          </a:p>
+        </p:txBody>
+      </p:sp>
+      <p:sp>
+        <p:nvSpPr>
+          <p:cNvPr id="105" name="FunnelTip_1"/>
+          <p:cNvSpPr txBox="1"/>
+          <p:nvPr/>
+        </p:nvSpPr>
+        <p:spPr>
+          <a:xfrm>
+            <a:off x="1143000" y="2254977"/>
+            <a:ext cx="4439868" cy="260000"/>
+          </a:xfrm>
+          <a:prstGeom prst="rect">
+            <a:avLst/>
+          </a:prstGeom>
+          <a:noFill/>
+          <a:ln>
+            <a:noFill/>
+          </a:ln>
+        </p:spPr>
+        <p:txBody>
+          <a:bodyPr wrap="none" lIns="0" tIns="0" rIns="0" bIns="0" anchor="ctr" anchorCtr="0">
+            <a:noAutofit/>
+          </a:bodyPr>
+          <a:lstStyle/>
+          <a:p>
+            <a:pPr algn="r" rtl="1"/>
+            <a:r>
+              <a:rPr lang="he-IL" sz="1300" b="1" dirty="0">
+                <a:solidFill>
+                  <a:srgbClr val="002F6C"/>
+                </a:solidFill>
+                <a:latin typeface="+mn-lt"/>
+                <a:cs typeface="+mn-lt"/>
+              </a:rPr>
+              <a:t>19.1%   5.2 ₪ מיליון</a:t>
+            </a:r>
+          </a:p>
+        </p:txBody>
+      </p:sp>
+      <p:sp>
+        <p:nvSpPr>
+          <p:cNvPr id="106" name="FunnelBar_קופות"/>
+          <p:cNvSpPr/>
+          <p:nvPr/>
+        </p:nvSpPr>
+        <p:spPr>
+          <a:xfrm>
+            <a:off x="6307933" y="2786441"/>
+            <a:ext cx="3201067" cy="621418"/>
+          </a:xfrm>
+          <a:prstGeom prst="rect">
+            <a:avLst/>
+          </a:prstGeom>
+          <a:solidFill>
+            <a:srgbClr val="1D4881"/>
+          </a:solidFill>
+          <a:ln>
+            <a:noFill/>
+          </a:ln>
+        </p:spPr>
+        <p:txBody>
+          <a:bodyPr/>
+          <a:lstStyle/>
+          <a:p>
+            <a:endParaRPr lang="he-IL"/>
+          </a:p>
+        </p:txBody>
+      </p:sp>
+      <p:sp>
+        <p:nvSpPr>
+          <p:cNvPr id="107" name="FunnelName_2"/>
+          <p:cNvSpPr txBox="1"/>
+          <p:nvPr/>
+        </p:nvSpPr>
+        <p:spPr>
+          <a:xfrm>
+            <a:off x="9549000" y="2967150"/>
+            <a:ext cx="1500000" cy="260000"/>
+          </a:xfrm>
+          <a:prstGeom prst="rect">
+            <a:avLst/>
+          </a:prstGeom>
+          <a:noFill/>
+          <a:ln>
+            <a:noFill/>
+          </a:ln>
+        </p:spPr>
+        <p:txBody>
+          <a:bodyPr wrap="none" lIns="0" tIns="0" rIns="0" bIns="0" anchor="ctr" anchorCtr="0">
+            <a:noAutofit/>
+          </a:bodyPr>
+          <a:lstStyle/>
+          <a:p>
+            <a:pPr algn="r" rtl="1"/>
+            <a:r>
+              <a:rPr lang="he-IL" sz="1300" b="1" dirty="0">
+                <a:solidFill>
+                  <a:srgbClr val="002F6C"/>
+                </a:solidFill>
+                <a:latin typeface="+mn-lt"/>
+                <a:cs typeface="+mn-lt"/>
+              </a:rPr>
+              <a:t>קופות</a:t>
+            </a:r>
+          </a:p>
+        </p:txBody>
+      </p:sp>
+      <p:sp>
+        <p:nvSpPr>
+          <p:cNvPr id="108" name="FunnelTip_2"/>
+          <p:cNvSpPr txBox="1"/>
+          <p:nvPr/>
+        </p:nvSpPr>
+        <p:spPr>
+          <a:xfrm>
+            <a:off x="1143000" y="2967150"/>
+            <a:ext cx="5104933" cy="260000"/>
+          </a:xfrm>
+          <a:prstGeom prst="rect">
+            <a:avLst/>
+          </a:prstGeom>
+          <a:noFill/>
+          <a:ln>
+            <a:noFill/>
+          </a:ln>
+        </p:spPr>
+        <p:txBody>
+          <a:bodyPr wrap="none" lIns="0" tIns="0" rIns="0" bIns="0" anchor="ctr" anchorCtr="0">
+            <a:noAutofit/>
+          </a:bodyPr>
+          <a:lstStyle/>
+          <a:p>
+            <a:pPr algn="r" rtl="1"/>
+            <a:r>
+              <a:rPr lang="he-IL" sz="1300" b="1" dirty="0">
+                <a:solidFill>
+                  <a:srgbClr val="002F6C"/>
+                </a:solidFill>
+                <a:latin typeface="+mn-lt"/>
+                <a:cs typeface="+mn-lt"/>
+              </a:rPr>
+              <a:t>15.8%   4.3 ₪ מיליון</a:t>
+            </a:r>
+          </a:p>
+        </p:txBody>
+      </p:sp>
+      <p:sp>
+        <p:nvSpPr>
+          <p:cNvPr id="109" name="FunnelBar_מפיצים"/>
+          <p:cNvSpPr/>
+          <p:nvPr/>
+        </p:nvSpPr>
+        <p:spPr>
+          <a:xfrm>
+            <a:off x="7282838" y="3467859"/>
+            <a:ext cx="2226162" cy="518221"/>
+          </a:xfrm>
+          <a:prstGeom prst="rect">
+            <a:avLst/>
+          </a:prstGeom>
+          <a:solidFill>
+            <a:srgbClr val="3A6095"/>
+          </a:solidFill>
+          <a:ln>
+            <a:noFill/>
+          </a:ln>
+        </p:spPr>
+        <p:txBody>
+          <a:bodyPr/>
+          <a:lstStyle/>
+          <a:p>
+            <a:endParaRPr lang="he-IL"/>
+          </a:p>
+        </p:txBody>
+      </p:sp>
+      <p:sp>
+        <p:nvSpPr>
+          <p:cNvPr id="110" name="FunnelName_3"/>
+          <p:cNvSpPr txBox="1"/>
+          <p:nvPr/>
+        </p:nvSpPr>
+        <p:spPr>
+          <a:xfrm>
+            <a:off x="9549000" y="3596970"/>
+            <a:ext cx="1500000" cy="260000"/>
+          </a:xfrm>
+          <a:prstGeom prst="rect">
+            <a:avLst/>
+          </a:prstGeom>
+          <a:noFill/>
+          <a:ln>
+            <a:noFill/>
+          </a:ln>
+        </p:spPr>
+        <p:txBody>
+          <a:bodyPr wrap="none" lIns="0" tIns="0" rIns="0" bIns="0" anchor="ctr" anchorCtr="0">
+            <a:noAutofit/>
+          </a:bodyPr>
+          <a:lstStyle/>
+          <a:p>
+            <a:pPr algn="r" rtl="1"/>
+            <a:r>
+              <a:rPr lang="he-IL" sz="1300" b="1" dirty="0">
+                <a:solidFill>
+                  <a:srgbClr val="002F6C"/>
+                </a:solidFill>
+                <a:latin typeface="+mn-lt"/>
+                <a:cs typeface="+mn-lt"/>
+              </a:rPr>
+              <a:t>מפיצים</a:t>
+            </a:r>
+          </a:p>
+        </p:txBody>
+      </p:sp>
+      <p:sp>
+        <p:nvSpPr>
+          <p:cNvPr id="111" name="FunnelTip_3"/>
+          <p:cNvSpPr txBox="1"/>
+          <p:nvPr/>
+        </p:nvSpPr>
+        <p:spPr>
+          <a:xfrm>
+            <a:off x="1143000" y="3596970"/>
+            <a:ext cx="6079838" cy="260000"/>
+          </a:xfrm>
+          <a:prstGeom prst="rect">
+            <a:avLst/>
+          </a:prstGeom>
+          <a:noFill/>
+          <a:ln>
+            <a:noFill/>
+          </a:ln>
+        </p:spPr>
+        <p:txBody>
+          <a:bodyPr wrap="none" lIns="0" tIns="0" rIns="0" bIns="0" anchor="ctr" anchorCtr="0">
+            <a:noAutofit/>
+          </a:bodyPr>
+          <a:lstStyle/>
+          <a:p>
+            <a:pPr algn="r" rtl="1"/>
+            <a:r>
+              <a:rPr lang="he-IL" sz="1300" b="1" dirty="0">
+                <a:solidFill>
+                  <a:srgbClr val="002F6C"/>
+                </a:solidFill>
+                <a:latin typeface="+mn-lt"/>
+                <a:cs typeface="+mn-lt"/>
+              </a:rPr>
+              <a:t>11.0%   3.0 ₪ מיליון</a:t>
+            </a:r>
+          </a:p>
+        </p:txBody>
+      </p:sp>
+      <p:sp>
+        <p:nvSpPr>
+          <p:cNvPr id="112" name="FunnelBar_אמזון"/>
+          <p:cNvSpPr/>
+          <p:nvPr/>
+        </p:nvSpPr>
+        <p:spPr>
+          <a:xfrm>
+            <a:off x="7542163" y="4046080"/>
+            <a:ext cx="1966837" cy="487103"/>
+          </a:xfrm>
+          <a:prstGeom prst="rect">
+            <a:avLst/>
+          </a:prstGeom>
+          <a:solidFill>
+            <a:srgbClr val="5779AA"/>
+          </a:solidFill>
+          <a:ln>
+            <a:noFill/>
+          </a:ln>
+        </p:spPr>
+        <p:txBody>
+          <a:bodyPr/>
+          <a:lstStyle/>
+          <a:p>
+            <a:endParaRPr lang="he-IL"/>
+          </a:p>
+        </p:txBody>
+      </p:sp>
+      <p:sp>
+        <p:nvSpPr>
+          <p:cNvPr id="113" name="FunnelName_4"/>
+          <p:cNvSpPr txBox="1"/>
+          <p:nvPr/>
+        </p:nvSpPr>
+        <p:spPr>
+          <a:xfrm>
+            <a:off x="9549000" y="4159632"/>
+            <a:ext cx="1500000" cy="260000"/>
+          </a:xfrm>
+          <a:prstGeom prst="rect">
+            <a:avLst/>
+          </a:prstGeom>
+          <a:noFill/>
+          <a:ln>
+            <a:noFill/>
+          </a:ln>
+        </p:spPr>
+        <p:txBody>
+          <a:bodyPr wrap="none" lIns="0" tIns="0" rIns="0" bIns="0" anchor="ctr" anchorCtr="0">
+            <a:noAutofit/>
+          </a:bodyPr>
+          <a:lstStyle/>
+          <a:p>
+            <a:pPr algn="r" rtl="1"/>
+            <a:r>
+              <a:rPr lang="he-IL" sz="1300" b="1" dirty="0">
+                <a:solidFill>
+                  <a:srgbClr val="002F6C"/>
+                </a:solidFill>
+                <a:latin typeface="+mn-lt"/>
+                <a:cs typeface="+mn-lt"/>
+              </a:rPr>
+              <a:t>אמזון</a:t>
+            </a:r>
+          </a:p>
+        </p:txBody>
+      </p:sp>
+      <p:sp>
+        <p:nvSpPr>
+          <p:cNvPr id="114" name="FunnelTip_4"/>
+          <p:cNvSpPr txBox="1"/>
+          <p:nvPr/>
+        </p:nvSpPr>
+        <p:spPr>
+          <a:xfrm>
+            <a:off x="1143000" y="4159632"/>
+            <a:ext cx="6339163" cy="260000"/>
+          </a:xfrm>
+          <a:prstGeom prst="rect">
+            <a:avLst/>
+          </a:prstGeom>
+          <a:noFill/>
+          <a:ln>
+            <a:noFill/>
+          </a:ln>
+        </p:spPr>
+        <p:txBody>
+          <a:bodyPr wrap="none" lIns="0" tIns="0" rIns="0" bIns="0" anchor="ctr" anchorCtr="0">
+            <a:noAutofit/>
+          </a:bodyPr>
+          <a:lstStyle/>
+          <a:p>
+            <a:pPr algn="r" rtl="1"/>
+            <a:r>
+              <a:rPr lang="he-IL" sz="1300" b="1" dirty="0">
+                <a:solidFill>
+                  <a:srgbClr val="002F6C"/>
+                </a:solidFill>
+                <a:latin typeface="+mn-lt"/>
+                <a:cs typeface="+mn-lt"/>
+              </a:rPr>
+              <a:t>9.7%   2.7 ₪ מיליון</a:t>
+            </a:r>
+          </a:p>
+        </p:txBody>
+      </p:sp>
+      <p:sp>
+        <p:nvSpPr>
+          <p:cNvPr id="115" name="FunnelBar_בתי מרקחת"/>
+          <p:cNvSpPr/>
+          <p:nvPr/>
+        </p:nvSpPr>
+        <p:spPr>
+          <a:xfrm>
+            <a:off x="8071860" y="4593183"/>
+            <a:ext cx="1437140" cy="416377"/>
+          </a:xfrm>
+          <a:prstGeom prst="rect">
+            <a:avLst/>
+          </a:prstGeom>
+          <a:solidFill>
+            <a:srgbClr val="7392BE"/>
+          </a:solidFill>
+          <a:ln>
+            <a:noFill/>
+          </a:ln>
+        </p:spPr>
+        <p:txBody>
+          <a:bodyPr/>
+          <a:lstStyle/>
+          <a:p>
+            <a:endParaRPr lang="he-IL"/>
+          </a:p>
+        </p:txBody>
+      </p:sp>
+      <p:sp>
+        <p:nvSpPr>
+          <p:cNvPr id="116" name="FunnelName_5"/>
+          <p:cNvSpPr txBox="1"/>
+          <p:nvPr/>
+        </p:nvSpPr>
+        <p:spPr>
+          <a:xfrm>
+            <a:off x="9549000" y="4671372"/>
+            <a:ext cx="1500000" cy="260000"/>
+          </a:xfrm>
+          <a:prstGeom prst="rect">
+            <a:avLst/>
+          </a:prstGeom>
+          <a:noFill/>
+          <a:ln>
+            <a:noFill/>
+          </a:ln>
+        </p:spPr>
+        <p:txBody>
+          <a:bodyPr wrap="none" lIns="0" tIns="0" rIns="0" bIns="0" anchor="ctr" anchorCtr="0">
+            <a:noAutofit/>
+          </a:bodyPr>
+          <a:lstStyle/>
+          <a:p>
+            <a:pPr algn="r" rtl="1"/>
+            <a:r>
+              <a:rPr lang="he-IL" sz="1300" b="1" dirty="0">
+                <a:solidFill>
+                  <a:srgbClr val="002F6C"/>
+                </a:solidFill>
+                <a:latin typeface="+mn-lt"/>
+                <a:cs typeface="+mn-lt"/>
+              </a:rPr>
+              <a:t>בתי מרקחת</a:t>
+            </a:r>
+          </a:p>
+        </p:txBody>
+      </p:sp>
+      <p:sp>
+        <p:nvSpPr>
+          <p:cNvPr id="117" name="FunnelTip_5"/>
+          <p:cNvSpPr txBox="1"/>
+          <p:nvPr/>
+        </p:nvSpPr>
+        <p:spPr>
+          <a:xfrm>
+            <a:off x="1143000" y="4671372"/>
+            <a:ext cx="6868860" cy="260000"/>
+          </a:xfrm>
+          <a:prstGeom prst="rect">
+            <a:avLst/>
+          </a:prstGeom>
+          <a:noFill/>
+          <a:ln>
+            <a:noFill/>
+          </a:ln>
+        </p:spPr>
+        <p:txBody>
+          <a:bodyPr wrap="none" lIns="0" tIns="0" rIns="0" bIns="0" anchor="ctr" anchorCtr="0">
+            <a:noAutofit/>
+          </a:bodyPr>
+          <a:lstStyle/>
+          <a:p>
+            <a:pPr algn="r" rtl="1"/>
+            <a:r>
+              <a:rPr lang="he-IL" sz="1300" b="1" dirty="0">
+                <a:solidFill>
+                  <a:srgbClr val="002F6C"/>
+                </a:solidFill>
+                <a:latin typeface="+mn-lt"/>
+                <a:cs typeface="+mn-lt"/>
+              </a:rPr>
+              <a:t>7.1%   1.9 ₪ מיליון</a:t>
+            </a:r>
+          </a:p>
+        </p:txBody>
+      </p:sp>
+      <p:sp>
+        <p:nvSpPr>
+          <p:cNvPr id="118" name="FunnelBar_מכונים"/>
+          <p:cNvSpPr/>
+          <p:nvPr/>
+        </p:nvSpPr>
+        <p:spPr>
+          <a:xfrm>
+            <a:off x="8675727" y="5069560"/>
+            <a:ext cx="833273" cy="317052"/>
+          </a:xfrm>
+          <a:prstGeom prst="rect">
+            <a:avLst/>
+          </a:prstGeom>
+          <a:solidFill>
+            <a:srgbClr val="90ABD3"/>
+          </a:solidFill>
+          <a:ln>
+            <a:noFill/>
+          </a:ln>
+        </p:spPr>
+        <p:txBody>
+          <a:bodyPr/>
+          <a:lstStyle/>
+          <a:p>
+            <a:endParaRPr lang="he-IL"/>
+          </a:p>
+        </p:txBody>
+      </p:sp>
+      <p:sp>
+        <p:nvSpPr>
+          <p:cNvPr id="119" name="FunnelName_6"/>
+          <p:cNvSpPr txBox="1"/>
+          <p:nvPr/>
+        </p:nvSpPr>
+        <p:spPr>
+          <a:xfrm>
+            <a:off x="9549000" y="5098086"/>
+            <a:ext cx="1500000" cy="260000"/>
+          </a:xfrm>
+          <a:prstGeom prst="rect">
+            <a:avLst/>
+          </a:prstGeom>
+          <a:noFill/>
+          <a:ln>
+            <a:noFill/>
+          </a:ln>
+        </p:spPr>
+        <p:txBody>
+          <a:bodyPr wrap="none" lIns="0" tIns="0" rIns="0" bIns="0" anchor="ctr" anchorCtr="0">
+            <a:noAutofit/>
+          </a:bodyPr>
+          <a:lstStyle/>
+          <a:p>
+            <a:pPr algn="r" rtl="1"/>
+            <a:r>
+              <a:rPr lang="he-IL" sz="1300" b="1" dirty="0">
+                <a:solidFill>
+                  <a:srgbClr val="002F6C"/>
+                </a:solidFill>
+                <a:latin typeface="+mn-lt"/>
+                <a:cs typeface="+mn-lt"/>
+              </a:rPr>
+              <a:t>מכונים</a:t>
+            </a:r>
+          </a:p>
+        </p:txBody>
+      </p:sp>
+      <p:sp>
+        <p:nvSpPr>
+          <p:cNvPr id="120" name="FunnelTip_6"/>
+          <p:cNvSpPr txBox="1"/>
+          <p:nvPr/>
+        </p:nvSpPr>
+        <p:spPr>
+          <a:xfrm>
+            <a:off x="1143000" y="5098086"/>
+            <a:ext cx="7472727" cy="260000"/>
+          </a:xfrm>
+          <a:prstGeom prst="rect">
+            <a:avLst/>
+          </a:prstGeom>
+          <a:noFill/>
+          <a:ln>
+            <a:noFill/>
+          </a:ln>
+        </p:spPr>
+        <p:txBody>
+          <a:bodyPr wrap="none" lIns="0" tIns="0" rIns="0" bIns="0" anchor="ctr" anchorCtr="0">
+            <a:noAutofit/>
+          </a:bodyPr>
+          <a:lstStyle/>
+          <a:p>
+            <a:pPr algn="r" rtl="1"/>
+            <a:r>
+              <a:rPr lang="he-IL" sz="1300" b="1" dirty="0">
+                <a:solidFill>
+                  <a:srgbClr val="002F6C"/>
+                </a:solidFill>
+                <a:latin typeface="+mn-lt"/>
+                <a:cs typeface="+mn-lt"/>
+              </a:rPr>
+              <a:t>4.1%   1.1 ₪ מיליון</a:t>
+            </a:r>
+          </a:p>
+        </p:txBody>
+      </p:sp>
+      <p:sp>
+        <p:nvSpPr>
+          <p:cNvPr id="121" name="FunnelBar_BE"/>
+          <p:cNvSpPr/>
+          <p:nvPr/>
+        </p:nvSpPr>
+        <p:spPr>
+          <a:xfrm>
+            <a:off x="8796318" y="5446612"/>
+            <a:ext cx="712682" cy="293214"/>
+          </a:xfrm>
+          <a:prstGeom prst="rect">
+            <a:avLst/>
+          </a:prstGeom>
+          <a:solidFill>
+            <a:srgbClr val="ADC3E7"/>
+          </a:solidFill>
+          <a:ln>
+            <a:noFill/>
+          </a:ln>
+        </p:spPr>
+        <p:txBody>
+          <a:bodyPr/>
+          <a:lstStyle/>
+          <a:p>
+            <a:endParaRPr lang="he-IL"/>
+          </a:p>
+        </p:txBody>
+      </p:sp>
+      <p:sp>
+        <p:nvSpPr>
+          <p:cNvPr id="122" name="FunnelName_7"/>
+          <p:cNvSpPr txBox="1"/>
+          <p:nvPr/>
+        </p:nvSpPr>
+        <p:spPr>
+          <a:xfrm>
+            <a:off x="9549000" y="5463219"/>
+            <a:ext cx="1500000" cy="260000"/>
+          </a:xfrm>
+          <a:prstGeom prst="rect">
+            <a:avLst/>
+          </a:prstGeom>
+          <a:noFill/>
+          <a:ln>
+            <a:noFill/>
+          </a:ln>
+        </p:spPr>
+        <p:txBody>
+          <a:bodyPr wrap="none" lIns="0" tIns="0" rIns="0" bIns="0" anchor="ctr" anchorCtr="0">
+            <a:noAutofit/>
+          </a:bodyPr>
+          <a:lstStyle/>
+          <a:p>
+            <a:pPr algn="r" rtl="1"/>
+            <a:r>
+              <a:rPr lang="he-IL" sz="1300" b="1" dirty="0">
+                <a:solidFill>
+                  <a:srgbClr val="002F6C"/>
+                </a:solidFill>
+                <a:latin typeface="+mn-lt"/>
+                <a:cs typeface="+mn-lt"/>
+              </a:rPr>
+              <a:t>BE</a:t>
+            </a:r>
+          </a:p>
+        </p:txBody>
+      </p:sp>
+      <p:sp>
+        <p:nvSpPr>
+          <p:cNvPr id="123" name="FunnelTip_7"/>
+          <p:cNvSpPr txBox="1"/>
+          <p:nvPr/>
+        </p:nvSpPr>
+        <p:spPr>
+          <a:xfrm>
+            <a:off x="1143000" y="5463219"/>
+            <a:ext cx="7593318" cy="260000"/>
+          </a:xfrm>
+          <a:prstGeom prst="rect">
+            <a:avLst/>
+          </a:prstGeom>
+          <a:noFill/>
+          <a:ln>
+            <a:noFill/>
+          </a:ln>
+        </p:spPr>
+        <p:txBody>
+          <a:bodyPr wrap="none" lIns="0" tIns="0" rIns="0" bIns="0" anchor="ctr" anchorCtr="0">
+            <a:noAutofit/>
+          </a:bodyPr>
+          <a:lstStyle/>
+          <a:p>
+            <a:pPr algn="r" rtl="1"/>
+            <a:r>
+              <a:rPr lang="he-IL" sz="1300" b="1" dirty="0">
+                <a:solidFill>
+                  <a:srgbClr val="002F6C"/>
+                </a:solidFill>
+                <a:latin typeface="+mn-lt"/>
+                <a:cs typeface="+mn-lt"/>
+              </a:rPr>
+              <a:t>3.5%   1.0 ₪ מיליון</a:t>
+            </a:r>
+          </a:p>
+        </p:txBody>
+      </p:sp>
+      <p:sp>
+        <p:nvSpPr>
+          <p:cNvPr id="124" name="FunnelBar_אחרים"/>
+          <p:cNvSpPr/>
+          <p:nvPr/>
+        </p:nvSpPr>
+        <p:spPr>
+          <a:xfrm>
+            <a:off x="9337651" y="5799826"/>
+            <a:ext cx="171349" cy="143774"/>
+          </a:xfrm>
+          <a:prstGeom prst="rect">
+            <a:avLst/>
+          </a:prstGeom>
+          <a:solidFill>
+            <a:srgbClr val="CADCFC"/>
+          </a:solidFill>
+          <a:ln>
+            <a:noFill/>
+          </a:ln>
+        </p:spPr>
+        <p:txBody>
+          <a:bodyPr/>
+          <a:lstStyle/>
+          <a:p>
+            <a:endParaRPr lang="he-IL"/>
+          </a:p>
+        </p:txBody>
+      </p:sp>
+      <p:sp>
+        <p:nvSpPr>
+          <p:cNvPr id="125" name="FunnelName_8"/>
+          <p:cNvSpPr txBox="1"/>
+          <p:nvPr/>
+        </p:nvSpPr>
+        <p:spPr>
+          <a:xfrm>
+            <a:off x="9549000" y="5741713"/>
+            <a:ext cx="1500000" cy="260000"/>
+          </a:xfrm>
+          <a:prstGeom prst="rect">
+            <a:avLst/>
+          </a:prstGeom>
+          <a:noFill/>
+          <a:ln>
+            <a:noFill/>
+          </a:ln>
+        </p:spPr>
+        <p:txBody>
+          <a:bodyPr wrap="none" lIns="0" tIns="0" rIns="0" bIns="0" anchor="ctr" anchorCtr="0">
+            <a:noAutofit/>
+          </a:bodyPr>
+          <a:lstStyle/>
+          <a:p>
+            <a:pPr algn="r" rtl="1"/>
+            <a:r>
+              <a:rPr lang="he-IL" sz="1300" b="1" dirty="0">
+                <a:solidFill>
+                  <a:srgbClr val="002F6C"/>
+                </a:solidFill>
+                <a:latin typeface="+mn-lt"/>
+                <a:cs typeface="+mn-lt"/>
+              </a:rPr>
+              <a:t>אחרים</a:t>
+            </a:r>
+          </a:p>
+        </p:txBody>
+      </p:sp>
+      <p:sp>
+        <p:nvSpPr>
+          <p:cNvPr id="126" name="FunnelTip_8"/>
+          <p:cNvSpPr txBox="1"/>
+          <p:nvPr/>
+        </p:nvSpPr>
+        <p:spPr>
+          <a:xfrm>
+            <a:off x="1143000" y="5741713"/>
+            <a:ext cx="8134651" cy="260000"/>
+          </a:xfrm>
+          <a:prstGeom prst="rect">
+            <a:avLst/>
+          </a:prstGeom>
+          <a:noFill/>
+          <a:ln>
+            <a:noFill/>
+          </a:ln>
+        </p:spPr>
+        <p:txBody>
+          <a:bodyPr wrap="none" lIns="0" tIns="0" rIns="0" bIns="0" anchor="ctr" anchorCtr="0">
+            <a:noAutofit/>
+          </a:bodyPr>
+          <a:lstStyle/>
+          <a:p>
+            <a:pPr algn="r" rtl="1"/>
+            <a:r>
+              <a:rPr lang="he-IL" sz="1300" b="1" dirty="0">
+                <a:solidFill>
+                  <a:srgbClr val="002F6C"/>
+                </a:solidFill>
+                <a:latin typeface="+mn-lt"/>
+                <a:cs typeface="+mn-lt"/>
+              </a:rPr>
+              <a:t>0.8%   0.2 ₪ מיליון</a:t>
+            </a:r>
+          </a:p>
+        </p:txBody>
+      </p:sp>
       <p:sp>
         <p:nvSpPr>
           <p:cNvPr id="4" name="Google Shape;107;g341c3af2acd_1_217">

</xml_diff>